<commit_message>
Fixed bug in penalization and in to_params.ExtrudeZ
</commit_message>
<xml_diff>
--- a/Slides/MMTOBenchmarkStudy.pptx
+++ b/Slides/MMTOBenchmarkStudy.pptx
@@ -12,7 +12,7 @@
     <p:sldId id="2352" r:id="rId3"/>
     <p:sldId id="2343" r:id="rId4"/>
     <p:sldId id="2381" r:id="rId5"/>
-    <p:sldId id="2382" r:id="rId6"/>
+    <p:sldId id="2384" r:id="rId6"/>
     <p:sldId id="2383" r:id="rId7"/>
   </p:sldIdLst>
   <p:sldSz cx="12192000" cy="6858000"/>
@@ -202,7 +202,7 @@
           <a:p>
             <a:fld id="{317BC63F-E652-456B-B880-2F318D1A1929}" type="datetimeFigureOut">
               <a:rPr lang="en-US" smtClean="0"/>
-              <a:t>10/23/2025</a:t>
+              <a:t>10/25/2025</a:t>
             </a:fld>
             <a:endParaRPr lang="en-US"/>
           </a:p>
@@ -616,7 +616,7 @@
           <a:p>
             <a:fld id="{935B4303-DE67-4DA8-B375-7E6264E8BDE4}" type="datetimeFigureOut">
               <a:rPr lang="en-US" smtClean="0"/>
-              <a:t>10/23/2025</a:t>
+              <a:t>10/25/2025</a:t>
             </a:fld>
             <a:endParaRPr lang="en-US"/>
           </a:p>
@@ -814,7 +814,7 @@
           <a:p>
             <a:fld id="{935B4303-DE67-4DA8-B375-7E6264E8BDE4}" type="datetimeFigureOut">
               <a:rPr lang="en-US" smtClean="0"/>
-              <a:t>10/23/2025</a:t>
+              <a:t>10/25/2025</a:t>
             </a:fld>
             <a:endParaRPr lang="en-US"/>
           </a:p>
@@ -1022,7 +1022,7 @@
           <a:p>
             <a:fld id="{935B4303-DE67-4DA8-B375-7E6264E8BDE4}" type="datetimeFigureOut">
               <a:rPr lang="en-US" smtClean="0"/>
-              <a:t>10/23/2025</a:t>
+              <a:t>10/25/2025</a:t>
             </a:fld>
             <a:endParaRPr lang="en-US"/>
           </a:p>
@@ -1532,7 +1532,7 @@
           <a:p>
             <a:fld id="{935B4303-DE67-4DA8-B375-7E6264E8BDE4}" type="datetimeFigureOut">
               <a:rPr lang="en-US" smtClean="0"/>
-              <a:t>10/23/2025</a:t>
+              <a:t>10/25/2025</a:t>
             </a:fld>
             <a:endParaRPr lang="en-US"/>
           </a:p>
@@ -1807,7 +1807,7 @@
           <a:p>
             <a:fld id="{935B4303-DE67-4DA8-B375-7E6264E8BDE4}" type="datetimeFigureOut">
               <a:rPr lang="en-US" smtClean="0"/>
-              <a:t>10/23/2025</a:t>
+              <a:t>10/25/2025</a:t>
             </a:fld>
             <a:endParaRPr lang="en-US"/>
           </a:p>
@@ -2072,7 +2072,7 @@
           <a:p>
             <a:fld id="{935B4303-DE67-4DA8-B375-7E6264E8BDE4}" type="datetimeFigureOut">
               <a:rPr lang="en-US" smtClean="0"/>
-              <a:t>10/23/2025</a:t>
+              <a:t>10/25/2025</a:t>
             </a:fld>
             <a:endParaRPr lang="en-US"/>
           </a:p>
@@ -2484,7 +2484,7 @@
           <a:p>
             <a:fld id="{935B4303-DE67-4DA8-B375-7E6264E8BDE4}" type="datetimeFigureOut">
               <a:rPr lang="en-US" smtClean="0"/>
-              <a:t>10/23/2025</a:t>
+              <a:t>10/25/2025</a:t>
             </a:fld>
             <a:endParaRPr lang="en-US"/>
           </a:p>
@@ -2625,7 +2625,7 @@
           <a:p>
             <a:fld id="{935B4303-DE67-4DA8-B375-7E6264E8BDE4}" type="datetimeFigureOut">
               <a:rPr lang="en-US" smtClean="0"/>
-              <a:t>10/23/2025</a:t>
+              <a:t>10/25/2025</a:t>
             </a:fld>
             <a:endParaRPr lang="en-US"/>
           </a:p>
@@ -2738,7 +2738,7 @@
           <a:p>
             <a:fld id="{935B4303-DE67-4DA8-B375-7E6264E8BDE4}" type="datetimeFigureOut">
               <a:rPr lang="en-US" smtClean="0"/>
-              <a:t>10/23/2025</a:t>
+              <a:t>10/25/2025</a:t>
             </a:fld>
             <a:endParaRPr lang="en-US"/>
           </a:p>
@@ -3049,7 +3049,7 @@
           <a:p>
             <a:fld id="{935B4303-DE67-4DA8-B375-7E6264E8BDE4}" type="datetimeFigureOut">
               <a:rPr lang="en-US" smtClean="0"/>
-              <a:t>10/23/2025</a:t>
+              <a:t>10/25/2025</a:t>
             </a:fld>
             <a:endParaRPr lang="en-US"/>
           </a:p>
@@ -3337,7 +3337,7 @@
           <a:p>
             <a:fld id="{935B4303-DE67-4DA8-B375-7E6264E8BDE4}" type="datetimeFigureOut">
               <a:rPr lang="en-US" smtClean="0"/>
-              <a:t>10/23/2025</a:t>
+              <a:t>10/25/2025</a:t>
             </a:fld>
             <a:endParaRPr lang="en-US"/>
           </a:p>
@@ -3578,7 +3578,7 @@
           <a:p>
             <a:fld id="{935B4303-DE67-4DA8-B375-7E6264E8BDE4}" type="datetimeFigureOut">
               <a:rPr lang="en-US" smtClean="0"/>
-              <a:t>10/23/2025</a:t>
+              <a:t>10/25/2025</a:t>
             </a:fld>
             <a:endParaRPr lang="en-US"/>
           </a:p>
@@ -5123,10 +5123,10 @@
       </p:sp>
       <p:pic>
         <p:nvPicPr>
-          <p:cNvPr id="6" name="Picture 5">
-            <a:extLst>
-              <a:ext uri="{FF2B5EF4-FFF2-40B4-BE49-F238E27FC236}">
-                <a16:creationId xmlns:a16="http://schemas.microsoft.com/office/drawing/2014/main" id="{0E5A1AC9-6AF9-2B23-D325-21365AAAE677}"/>
+          <p:cNvPr id="4" name="Picture 3">
+            <a:extLst>
+              <a:ext uri="{FF2B5EF4-FFF2-40B4-BE49-F238E27FC236}">
+                <a16:creationId xmlns:a16="http://schemas.microsoft.com/office/drawing/2014/main" id="{B9009068-ADF7-FF22-614A-32D2D663C674}"/>
               </a:ext>
             </a:extLst>
           </p:cNvPr>
@@ -5143,8 +5143,8 @@
         </p:blipFill>
         <p:spPr>
           <a:xfrm>
-            <a:off x="467996" y="2190721"/>
-            <a:ext cx="6357951" cy="1933604"/>
+            <a:off x="581842" y="1882063"/>
+            <a:ext cx="3935550" cy="1375701"/>
           </a:xfrm>
           <a:prstGeom prst="rect">
             <a:avLst/>
@@ -5262,12 +5262,107 @@
           </a:p>
         </p:txBody>
       </p:sp>
+      <p:sp>
+        <p:nvSpPr>
+          <p:cNvPr id="11" name="TextBox 10">
+            <a:extLst>
+              <a:ext uri="{FF2B5EF4-FFF2-40B4-BE49-F238E27FC236}">
+                <a16:creationId xmlns:a16="http://schemas.microsoft.com/office/drawing/2014/main" id="{446718E9-9378-824E-D79E-0C71AA53EC1F}"/>
+              </a:ext>
+            </a:extLst>
+          </p:cNvPr>
+          <p:cNvSpPr txBox="1"/>
+          <p:nvPr/>
+        </p:nvSpPr>
+        <p:spPr>
+          <a:xfrm>
+            <a:off x="1188947" y="4318977"/>
+            <a:ext cx="2969083" cy="461665"/>
+          </a:xfrm>
+          <a:prstGeom prst="rect">
+            <a:avLst/>
+          </a:prstGeom>
+          <a:noFill/>
+        </p:spPr>
+        <p:txBody>
+          <a:bodyPr wrap="none" rtlCol="0">
+            <a:spAutoFit/>
+          </a:bodyPr>
+          <a:lstStyle/>
+          <a:p>
+            <a:pPr algn="ctr"/>
+            <a:r>
+              <a:rPr lang="en-US" sz="2400" b="1" dirty="0"/>
+              <a:t>Compliance: </a:t>
+            </a:r>
+            <a:r>
+              <a:rPr lang="en-US" sz="2400" b="1" dirty="0">
+                <a:solidFill>
+                  <a:srgbClr val="00B050"/>
+                </a:solidFill>
+              </a:rPr>
+              <a:t>243.56</a:t>
+            </a:r>
+          </a:p>
+        </p:txBody>
+      </p:sp>
+      <p:sp>
+        <p:nvSpPr>
+          <p:cNvPr id="7" name="TextBox 6">
+            <a:extLst>
+              <a:ext uri="{FF2B5EF4-FFF2-40B4-BE49-F238E27FC236}">
+                <a16:creationId xmlns:a16="http://schemas.microsoft.com/office/drawing/2014/main" id="{42A84B12-86D9-82E6-F95A-7AC000A02CA1}"/>
+              </a:ext>
+            </a:extLst>
+          </p:cNvPr>
+          <p:cNvSpPr txBox="1"/>
+          <p:nvPr/>
+        </p:nvSpPr>
+        <p:spPr>
+          <a:xfrm>
+            <a:off x="381000" y="1148884"/>
+            <a:ext cx="6094070" cy="267124"/>
+          </a:xfrm>
+          <a:prstGeom prst="rect">
+            <a:avLst/>
+          </a:prstGeom>
+          <a:noFill/>
+        </p:spPr>
+        <p:txBody>
+          <a:bodyPr wrap="square">
+            <a:spAutoFit/>
+          </a:bodyPr>
+          <a:lstStyle/>
+          <a:p>
+            <a:pPr>
+              <a:lnSpc>
+                <a:spcPts val="1200"/>
+              </a:lnSpc>
+              <a:buNone/>
+            </a:pPr>
+            <a:r>
+              <a:rPr lang="en-US" b="1" dirty="0" err="1">
+                <a:effectLst/>
+                <a:latin typeface="Consolas" panose="020B0609020204030204" pitchFamily="49" charset="0"/>
+              </a:rPr>
+              <a:t>to_params.RelativeFilterRadius</a:t>
+            </a:r>
+            <a:r>
+              <a:rPr lang="en-US" b="1" dirty="0">
+                <a:effectLst/>
+                <a:latin typeface="Consolas" panose="020B0609020204030204" pitchFamily="49" charset="0"/>
+              </a:rPr>
+              <a:t> = 1.5</a:t>
+            </a:r>
+          </a:p>
+        </p:txBody>
+      </p:sp>
       <p:pic>
         <p:nvPicPr>
-          <p:cNvPr id="6" name="Picture 5">
-            <a:extLst>
-              <a:ext uri="{FF2B5EF4-FFF2-40B4-BE49-F238E27FC236}">
-                <a16:creationId xmlns:a16="http://schemas.microsoft.com/office/drawing/2014/main" id="{6E2FEFA1-38C4-8BC9-D5A7-64BAB9019E13}"/>
+          <p:cNvPr id="12" name="Picture 11">
+            <a:extLst>
+              <a:ext uri="{FF2B5EF4-FFF2-40B4-BE49-F238E27FC236}">
+                <a16:creationId xmlns:a16="http://schemas.microsoft.com/office/drawing/2014/main" id="{43968B03-0D5F-6D51-A4A8-14946257AC71}"/>
               </a:ext>
             </a:extLst>
           </p:cNvPr>
@@ -5284,64 +5379,20 @@
         </p:blipFill>
         <p:spPr>
           <a:xfrm>
-            <a:off x="5346975" y="1009561"/>
-            <a:ext cx="1212912" cy="3448227"/>
+            <a:off x="526401" y="1517854"/>
+            <a:ext cx="5532731" cy="2475412"/>
           </a:xfrm>
           <a:prstGeom prst="rect">
             <a:avLst/>
           </a:prstGeom>
         </p:spPr>
       </p:pic>
-      <p:sp>
-        <p:nvSpPr>
-          <p:cNvPr id="11" name="TextBox 10">
-            <a:extLst>
-              <a:ext uri="{FF2B5EF4-FFF2-40B4-BE49-F238E27FC236}">
-                <a16:creationId xmlns:a16="http://schemas.microsoft.com/office/drawing/2014/main" id="{446718E9-9378-824E-D79E-0C71AA53EC1F}"/>
-              </a:ext>
-            </a:extLst>
-          </p:cNvPr>
-          <p:cNvSpPr txBox="1"/>
-          <p:nvPr/>
-        </p:nvSpPr>
-        <p:spPr>
-          <a:xfrm>
-            <a:off x="1188947" y="4318977"/>
-            <a:ext cx="2969083" cy="461665"/>
-          </a:xfrm>
-          <a:prstGeom prst="rect">
-            <a:avLst/>
-          </a:prstGeom>
-          <a:noFill/>
-        </p:spPr>
-        <p:txBody>
-          <a:bodyPr wrap="none" rtlCol="0">
-            <a:spAutoFit/>
-          </a:bodyPr>
-          <a:lstStyle/>
-          <a:p>
-            <a:pPr algn="ctr"/>
-            <a:r>
-              <a:rPr lang="en-US" sz="2400" b="1" dirty="0"/>
-              <a:t>Compliance: </a:t>
-            </a:r>
-            <a:r>
-              <a:rPr lang="en-US" sz="2400" b="1" dirty="0">
-                <a:solidFill>
-                  <a:srgbClr val="00B050"/>
-                </a:solidFill>
-              </a:rPr>
-              <a:t>243.36</a:t>
-            </a:r>
-          </a:p>
-        </p:txBody>
-      </p:sp>
       <p:pic>
         <p:nvPicPr>
-          <p:cNvPr id="5" name="Picture 4">
-            <a:extLst>
-              <a:ext uri="{FF2B5EF4-FFF2-40B4-BE49-F238E27FC236}">
-                <a16:creationId xmlns:a16="http://schemas.microsoft.com/office/drawing/2014/main" id="{3A9C94DD-94A0-0C58-2E79-7974451306E4}"/>
+          <p:cNvPr id="14" name="Picture 13">
+            <a:extLst>
+              <a:ext uri="{FF2B5EF4-FFF2-40B4-BE49-F238E27FC236}">
+                <a16:creationId xmlns:a16="http://schemas.microsoft.com/office/drawing/2014/main" id="{5514CE83-FE3D-4ECA-4E31-8710AF8DB42A}"/>
               </a:ext>
             </a:extLst>
           </p:cNvPr>
@@ -5358,8 +5409,8 @@
         </p:blipFill>
         <p:spPr>
           <a:xfrm>
-            <a:off x="6359913" y="1009561"/>
-            <a:ext cx="5670841" cy="4191215"/>
+            <a:off x="6715646" y="950090"/>
+            <a:ext cx="3828892" cy="2794057"/>
           </a:xfrm>
           <a:prstGeom prst="rect">
             <a:avLst/>
@@ -5368,10 +5419,10 @@
       </p:pic>
       <p:pic>
         <p:nvPicPr>
-          <p:cNvPr id="4" name="Picture 3">
-            <a:extLst>
-              <a:ext uri="{FF2B5EF4-FFF2-40B4-BE49-F238E27FC236}">
-                <a16:creationId xmlns:a16="http://schemas.microsoft.com/office/drawing/2014/main" id="{266453A4-80C8-A343-BB15-5149268514A5}"/>
+          <p:cNvPr id="18" name="Picture 17">
+            <a:extLst>
+              <a:ext uri="{FF2B5EF4-FFF2-40B4-BE49-F238E27FC236}">
+                <a16:creationId xmlns:a16="http://schemas.microsoft.com/office/drawing/2014/main" id="{C17D66F1-CC9B-9A66-CC56-0A494F9760F5}"/>
               </a:ext>
             </a:extLst>
           </p:cNvPr>
@@ -5388,8 +5439,8 @@
         </p:blipFill>
         <p:spPr>
           <a:xfrm>
-            <a:off x="276494" y="1702579"/>
-            <a:ext cx="5000758" cy="2534631"/>
+            <a:off x="6132870" y="3890962"/>
+            <a:ext cx="5678130" cy="2899382"/>
           </a:xfrm>
           <a:prstGeom prst="rect">
             <a:avLst/>
@@ -5398,10 +5449,10 @@
       </p:pic>
       <p:pic>
         <p:nvPicPr>
-          <p:cNvPr id="8" name="Picture 7">
-            <a:extLst>
-              <a:ext uri="{FF2B5EF4-FFF2-40B4-BE49-F238E27FC236}">
-                <a16:creationId xmlns:a16="http://schemas.microsoft.com/office/drawing/2014/main" id="{953806A2-C76D-FEFC-2DE5-BA1CAC9CC513}"/>
+          <p:cNvPr id="20" name="Picture 19">
+            <a:extLst>
+              <a:ext uri="{FF2B5EF4-FFF2-40B4-BE49-F238E27FC236}">
+                <a16:creationId xmlns:a16="http://schemas.microsoft.com/office/drawing/2014/main" id="{AB6AA792-6919-4CF5-6106-D7E0955E70CB}"/>
               </a:ext>
             </a:extLst>
           </p:cNvPr>
@@ -5418,8 +5469,8 @@
         </p:blipFill>
         <p:spPr>
           <a:xfrm>
-            <a:off x="381000" y="5200775"/>
-            <a:ext cx="5242021" cy="1341814"/>
+            <a:off x="410151" y="4840384"/>
+            <a:ext cx="5588529" cy="1768760"/>
           </a:xfrm>
           <a:prstGeom prst="rect">
             <a:avLst/>
@@ -5444,7 +5495,13 @@
   <p:cSld>
     <p:spTree>
       <p:nvGrpSpPr>
-        <p:cNvPr id="1" name=""/>
+        <p:cNvPr id="1" name="">
+          <a:extLst>
+            <a:ext uri="{FF2B5EF4-FFF2-40B4-BE49-F238E27FC236}">
+              <a16:creationId xmlns:a16="http://schemas.microsoft.com/office/drawing/2014/main" id="{6AF8615F-6FF6-42F0-F346-DCA5FE208F66}"/>
+            </a:ext>
+          </a:extLst>
+        </p:cNvPr>
         <p:cNvGrpSpPr/>
         <p:nvPr/>
       </p:nvGrpSpPr>
@@ -5458,10 +5515,50 @@
       </p:grpSpPr>
       <p:sp>
         <p:nvSpPr>
-          <p:cNvPr id="3" name="Title 2">
-            <a:extLst>
-              <a:ext uri="{FF2B5EF4-FFF2-40B4-BE49-F238E27FC236}">
-                <a16:creationId xmlns:a16="http://schemas.microsoft.com/office/drawing/2014/main" id="{C2041609-A8F6-FA19-E73A-BA6FF79C8244}"/>
+          <p:cNvPr id="3" name="Slide Number Placeholder 2">
+            <a:extLst>
+              <a:ext uri="{FF2B5EF4-FFF2-40B4-BE49-F238E27FC236}">
+                <a16:creationId xmlns:a16="http://schemas.microsoft.com/office/drawing/2014/main" id="{F8F8E8D1-7B3B-25F2-DB7F-5CE0597A3199}"/>
+              </a:ext>
+            </a:extLst>
+          </p:cNvPr>
+          <p:cNvSpPr>
+            <a:spLocks noGrp="1"/>
+          </p:cNvSpPr>
+          <p:nvPr>
+            <p:ph type="sldNum" sz="quarter" idx="11"/>
+          </p:nvPr>
+        </p:nvSpPr>
+        <p:spPr>
+          <a:xfrm>
+            <a:off x="8940799" y="6430254"/>
+            <a:ext cx="2743200" cy="365125"/>
+          </a:xfrm>
+        </p:spPr>
+        <p:txBody>
+          <a:bodyPr/>
+          <a:lstStyle/>
+          <a:p>
+            <a:pPr>
+              <a:defRPr/>
+            </a:pPr>
+            <a:fld id="{231CC523-8BC6-4921-807A-66BD262F34AB}" type="slidenum">
+              <a:rPr lang="en-US" smtClean="0"/>
+              <a:pPr>
+                <a:defRPr/>
+              </a:pPr>
+              <a:t>5</a:t>
+            </a:fld>
+            <a:endParaRPr lang="en-US"/>
+          </a:p>
+        </p:txBody>
+      </p:sp>
+      <p:sp>
+        <p:nvSpPr>
+          <p:cNvPr id="9" name="Title 8">
+            <a:extLst>
+              <a:ext uri="{FF2B5EF4-FFF2-40B4-BE49-F238E27FC236}">
+                <a16:creationId xmlns:a16="http://schemas.microsoft.com/office/drawing/2014/main" id="{A5C08549-AA26-4F91-E444-D300E8EE07C8}"/>
               </a:ext>
             </a:extLst>
           </p:cNvPr>
@@ -5472,24 +5569,136 @@
             <p:ph type="ctrTitle"/>
           </p:nvPr>
         </p:nvSpPr>
-        <p:spPr/>
-        <p:txBody>
-          <a:bodyPr/>
+        <p:spPr>
+          <a:xfrm>
+            <a:off x="381000" y="126366"/>
+            <a:ext cx="11302999" cy="612648"/>
+          </a:xfrm>
+        </p:spPr>
+        <p:txBody>
+          <a:bodyPr>
+            <a:normAutofit/>
+          </a:bodyPr>
           <a:lstStyle/>
           <a:p>
             <a:r>
               <a:rPr lang="en-US" dirty="0"/>
-              <a:t>Convergence Plots</a:t>
-            </a:r>
+              <a:t>Optimal Topology</a:t>
+            </a:r>
+          </a:p>
+        </p:txBody>
+      </p:sp>
+      <p:sp>
+        <p:nvSpPr>
+          <p:cNvPr id="11" name="TextBox 10">
+            <a:extLst>
+              <a:ext uri="{FF2B5EF4-FFF2-40B4-BE49-F238E27FC236}">
+                <a16:creationId xmlns:a16="http://schemas.microsoft.com/office/drawing/2014/main" id="{B31CDBE8-C6F2-B7E8-D2B0-67721357ED54}"/>
+              </a:ext>
+            </a:extLst>
+          </p:cNvPr>
+          <p:cNvSpPr txBox="1"/>
+          <p:nvPr/>
+        </p:nvSpPr>
+        <p:spPr>
+          <a:xfrm>
+            <a:off x="1188947" y="4318977"/>
+            <a:ext cx="2969083" cy="461665"/>
+          </a:xfrm>
+          <a:prstGeom prst="rect">
+            <a:avLst/>
+          </a:prstGeom>
+          <a:noFill/>
+        </p:spPr>
+        <p:txBody>
+          <a:bodyPr wrap="none" rtlCol="0">
+            <a:spAutoFit/>
+          </a:bodyPr>
+          <a:lstStyle/>
+          <a:p>
+            <a:pPr algn="ctr"/>
+            <a:r>
+              <a:rPr lang="en-US" sz="2400" b="1" dirty="0"/>
+              <a:t>Compliance: </a:t>
+            </a:r>
+            <a:r>
+              <a:rPr lang="en-US" sz="2400" b="1" dirty="0">
+                <a:solidFill>
+                  <a:srgbClr val="00B050"/>
+                </a:solidFill>
+              </a:rPr>
+              <a:t>245.65</a:t>
+            </a:r>
+          </a:p>
+        </p:txBody>
+      </p:sp>
+      <p:sp>
+        <p:nvSpPr>
+          <p:cNvPr id="7" name="TextBox 6">
+            <a:extLst>
+              <a:ext uri="{FF2B5EF4-FFF2-40B4-BE49-F238E27FC236}">
+                <a16:creationId xmlns:a16="http://schemas.microsoft.com/office/drawing/2014/main" id="{CFD57EC7-36D3-5583-E923-B959CD6722CF}"/>
+              </a:ext>
+            </a:extLst>
+          </p:cNvPr>
+          <p:cNvSpPr txBox="1"/>
+          <p:nvPr/>
+        </p:nvSpPr>
+        <p:spPr>
+          <a:xfrm>
+            <a:off x="381000" y="1148884"/>
+            <a:ext cx="6094070" cy="267124"/>
+          </a:xfrm>
+          <a:prstGeom prst="rect">
+            <a:avLst/>
+          </a:prstGeom>
+          <a:noFill/>
+        </p:spPr>
+        <p:txBody>
+          <a:bodyPr wrap="square">
+            <a:spAutoFit/>
+          </a:bodyPr>
+          <a:lstStyle/>
+          <a:p>
+            <a:pPr>
+              <a:lnSpc>
+                <a:spcPts val="1200"/>
+              </a:lnSpc>
+              <a:buNone/>
+            </a:pPr>
+            <a:r>
+              <a:rPr lang="en-US" b="1" dirty="0" err="1">
+                <a:effectLst/>
+                <a:latin typeface="Consolas" panose="020B0609020204030204" pitchFamily="49" charset="0"/>
+              </a:rPr>
+              <a:t>to_params.RelativeFilterRadius</a:t>
+            </a:r>
+            <a:r>
+              <a:rPr lang="en-US" b="1" dirty="0">
+                <a:effectLst/>
+                <a:latin typeface="Consolas" panose="020B0609020204030204" pitchFamily="49" charset="0"/>
+              </a:rPr>
+              <a:t> = </a:t>
+            </a:r>
+            <a:r>
+              <a:rPr lang="en-US" b="1" dirty="0">
+                <a:latin typeface="Consolas" panose="020B0609020204030204" pitchFamily="49" charset="0"/>
+              </a:rPr>
+              <a:t>3</a:t>
+            </a:r>
+            <a:endParaRPr lang="en-US" b="1" dirty="0">
+              <a:effectLst/>
+              <a:latin typeface="Consolas" panose="020B0609020204030204" pitchFamily="49" charset="0"/>
+            </a:endParaRPr>
           </a:p>
         </p:txBody>
       </p:sp>
       <p:pic>
         <p:nvPicPr>
-          <p:cNvPr id="4" name="Picture 3">
-            <a:extLst>
-              <a:ext uri="{FF2B5EF4-FFF2-40B4-BE49-F238E27FC236}">
-                <a16:creationId xmlns:a16="http://schemas.microsoft.com/office/drawing/2014/main" id="{D03A6462-B36F-32E8-8114-E467300AE26E}"/>
+          <p:cNvPr id="6" name="Picture 5">
+            <a:extLst>
+              <a:ext uri="{FF2B5EF4-FFF2-40B4-BE49-F238E27FC236}">
+                <a16:creationId xmlns:a16="http://schemas.microsoft.com/office/drawing/2014/main" id="{0221332E-1AAD-61EC-EA08-FB8D7442C695}"/>
               </a:ext>
             </a:extLst>
           </p:cNvPr>
@@ -5506,8 +5715,98 @@
         </p:blipFill>
         <p:spPr>
           <a:xfrm>
-            <a:off x="298195" y="1041267"/>
-            <a:ext cx="9919210" cy="5175516"/>
+            <a:off x="165684" y="1493680"/>
+            <a:ext cx="5466716" cy="2496684"/>
+          </a:xfrm>
+          <a:prstGeom prst="rect">
+            <a:avLst/>
+          </a:prstGeom>
+        </p:spPr>
+      </p:pic>
+      <p:pic>
+        <p:nvPicPr>
+          <p:cNvPr id="10" name="Picture 9">
+            <a:extLst>
+              <a:ext uri="{FF2B5EF4-FFF2-40B4-BE49-F238E27FC236}">
+                <a16:creationId xmlns:a16="http://schemas.microsoft.com/office/drawing/2014/main" id="{72F5A7C1-5096-4D56-AFC5-4A09903E766B}"/>
+              </a:ext>
+            </a:extLst>
+          </p:cNvPr>
+          <p:cNvPicPr>
+            <a:picLocks noChangeAspect="1"/>
+          </p:cNvPicPr>
+          <p:nvPr/>
+        </p:nvPicPr>
+        <p:blipFill>
+          <a:blip r:embed="rId3"/>
+          <a:stretch>
+            <a:fillRect/>
+          </a:stretch>
+        </p:blipFill>
+        <p:spPr>
+          <a:xfrm>
+            <a:off x="6397373" y="1071213"/>
+            <a:ext cx="3840706" cy="2919150"/>
+          </a:xfrm>
+          <a:prstGeom prst="rect">
+            <a:avLst/>
+          </a:prstGeom>
+        </p:spPr>
+      </p:pic>
+      <p:pic>
+        <p:nvPicPr>
+          <p:cNvPr id="15" name="Picture 14">
+            <a:extLst>
+              <a:ext uri="{FF2B5EF4-FFF2-40B4-BE49-F238E27FC236}">
+                <a16:creationId xmlns:a16="http://schemas.microsoft.com/office/drawing/2014/main" id="{7D36ECE9-CB89-5135-FE3C-E2F57639F0AA}"/>
+              </a:ext>
+            </a:extLst>
+          </p:cNvPr>
+          <p:cNvPicPr>
+            <a:picLocks noChangeAspect="1"/>
+          </p:cNvPicPr>
+          <p:nvPr/>
+        </p:nvPicPr>
+        <p:blipFill>
+          <a:blip r:embed="rId4"/>
+          <a:stretch>
+            <a:fillRect/>
+          </a:stretch>
+        </p:blipFill>
+        <p:spPr>
+          <a:xfrm>
+            <a:off x="5632400" y="3990363"/>
+            <a:ext cx="5370653" cy="2741271"/>
+          </a:xfrm>
+          <a:prstGeom prst="rect">
+            <a:avLst/>
+          </a:prstGeom>
+        </p:spPr>
+      </p:pic>
+      <p:pic>
+        <p:nvPicPr>
+          <p:cNvPr id="18" name="Picture 17">
+            <a:extLst>
+              <a:ext uri="{FF2B5EF4-FFF2-40B4-BE49-F238E27FC236}">
+                <a16:creationId xmlns:a16="http://schemas.microsoft.com/office/drawing/2014/main" id="{E1ED7F4E-9CA9-08A6-B3B1-772EB414E0B5}"/>
+              </a:ext>
+            </a:extLst>
+          </p:cNvPr>
+          <p:cNvPicPr>
+            <a:picLocks noChangeAspect="1"/>
+          </p:cNvPicPr>
+          <p:nvPr/>
+        </p:nvPicPr>
+        <p:blipFill>
+          <a:blip r:embed="rId5"/>
+          <a:stretch>
+            <a:fillRect/>
+          </a:stretch>
+        </p:blipFill>
+        <p:spPr>
+          <a:xfrm>
+            <a:off x="380999" y="4780642"/>
+            <a:ext cx="5392741" cy="1950992"/>
           </a:xfrm>
           <a:prstGeom prst="rect">
             <a:avLst/>
@@ -5517,7 +5816,7 @@
     </p:spTree>
     <p:extLst>
       <p:ext uri="{BB962C8B-B14F-4D97-AF65-F5344CB8AC3E}">
-        <p14:creationId xmlns:p14="http://schemas.microsoft.com/office/powerpoint/2010/main" val="3759327184"/>
+        <p14:creationId xmlns:p14="http://schemas.microsoft.com/office/powerpoint/2010/main" val="1917786277"/>
       </p:ext>
     </p:extLst>
   </p:cSld>

</xml_diff>